<commit_message>
docs: rewrite pitch deck YC-style — one anchor per slide
Strips ~70% of content density across 10 slides. Adds .hero CSS class
for centered single-anchor layouts (giant amber number / one-line code
/ punchy claim). Slide 2 reframes as "Pick one. Lose either way."
Slides 5-9 each lose tables and bullet stacks for a hero element +
one supporting line. Speaker notes intact — slides now reinforce the
voiceover instead of duplicating it. Title + closing slides hide all
chrome (no header / footer / page number) for ad-quality cleanliness.

Co-Authored-By: Claude Opus 4.7 (1M context) <noreply@anthropic.com>
</commit_message>
<xml_diff>
--- a/docs/PITCH-DECK.pptx
+++ b/docs/PITCH-DECK.pptx
@@ -511,11 +511,11 @@
           <a:p>
             <a:r>
               <a:rPr lang="en-US" dirty="0"/>
-              <a:t>SLIDE 1, 25 SECONDS.
-Every AI agent on-chain today is one prompt injection away from a drained
-wallet. Today you pick: hand a custodian your funds, or hand the agent
-your keys. Either way you lose. AgentGuard is the third option — the
-secure payments SDK for AI agents. Stripe-grade DX, keys never leave the user.</a:t>
+              <a:t>SLIDE 1, 20 SECONDS.
+AgentGuard is the safety layer for AI agents that spend money on-chain.
+Today you pick: hand a custodian your funds, or hand the agent your keys.
+Either way you lose. We built the third option — non-custodial, AI-aware,
+Stripe-grade DX. Keys never leave the user.</a:t>
             </a:r>
             <a:endParaRPr lang="en-US" dirty="0"/>
           </a:p>

</xml_diff>

<commit_message>
docs: expand pitch deck for judge-view clarity — 15 slides + dashboard shot
- add 5 substantive slides: what's shipped, differentiation, platform/marketplace, tech stack, roadmap
- reframe slide 3 to surface the 5-layers → 3-tiers mapping (AUTO/GUARD/HUMAN)
- inline glossary on architecture slide (TEE / EIP-7702 / Kernel v3.3)
- expand on-chain guard with the 3 stacked validator policies; add trigger list to human approve
- embed live-dashboard screenshot on what's-shipped to anchor the tier story visually

Co-Authored-By: Claude Opus 4.7 (1M context) <noreply@anthropic.com>
</commit_message>
<xml_diff>
--- a/docs/PITCH-DECK.pptx
+++ b/docs/PITCH-DECK.pptx
@@ -15,9 +15,14 @@
     <p:sldId id="263" r:id="rId9"/>
     <p:sldId id="264" r:id="rId10"/>
     <p:sldId id="265" r:id="rId11"/>
+    <p:sldId id="266" r:id="rId12"/>
+    <p:sldId id="267" r:id="rId13"/>
+    <p:sldId id="268" r:id="rId14"/>
+    <p:sldId id="269" r:id="rId15"/>
+    <p:sldId id="270" r:id="rId16"/>
   </p:sldIdLst>
   <p:notesMasterIdLst>
-    <p:notesMasterId r:id="rId12"/>
+    <p:notesMasterId r:id="rId17"/>
   </p:notesMasterIdLst>
   <p:sldSz cx="12192000" cy="6858000"/>
   <p:notesSz cx="6858000" cy="12192000"/>
@@ -604,13 +609,14 @@
             <a:r>
               <a:rPr lang="en-US" dirty="0"/>
               <a:t>SLIDE 10, 30 SECONDS.
-Three next moves, all on the primitives we shipped this week. MPP — Tempo's
-new payments protocol — half-day MVP. Multi-chain rolls out as soon as 7702
-+ ZeroDev support stabilizes elsewhere. And premium providers turn the
-platform into a revenue engine. We're applying to Privy, ZeroDev, Base, and
-OpenAI sponsor tracks — this product sits across all four. Repo and live
-demo are at this URL. We'd love follow-ups with anyone building agent infra.
-Thanks.</a:t>
+This is what's running today, not what's planned. Onboarding takes 30 seconds
+and ends with an API key the developer pastes into their agent. Policy editor
+hot-reloads. AI Guard catches intent drift live in the demo. Three execution
+tiers all wire into a single SDK call — the developer just awaits, the
+status field tells them which path was taken. x402 settles in about four
+seconds, which is the unit-economics number for micropayments. Emergency
+Stop is one Privy popup that sweeps the account and revokes the key in
+five seconds. Live URL is at the bottom — judges can sign up themselves.</a:t>
             </a:r>
             <a:endParaRPr lang="en-US" dirty="0"/>
           </a:p>
@@ -634,6 +640,482 @@
             <a:fld id="{F7021451-1387-4CA6-816F-3879F97B5CBC}" type="slidenum">
               <a:rPr lang="en-US"/>
               <a:t>10</a:t>
+            </a:fld>
+            <a:endParaRPr lang="en-US"/>
+          </a:p>
+        </p:txBody>
+      </p:sp>
+    </p:spTree>
+    <p:extLst>
+      <p:ext uri="{BB962C8B-B14F-4D97-AF65-F5344CB8AC3E}">
+        <p14:creationId xmlns:p14="http://schemas.microsoft.com/office/powerpoint/2010/main" val="1024086991"/>
+      </p:ext>
+    </p:extLst>
+  </p:cSld>
+  <p:clrMapOvr>
+    <a:masterClrMapping/>
+  </p:clrMapOvr>
+</p:notes>
+</file>
+
+<file path=ppt/notesSlides/notesSlide11.xml><?xml version="1.0" encoding="utf-8"?>
+<p:notes xmlns:a="http://schemas.openxmlformats.org/drawingml/2006/main" xmlns:r="http://schemas.openxmlformats.org/officeDocument/2006/relationships" xmlns:p="http://schemas.openxmlformats.org/presentationml/2006/main">
+  <p:cSld>
+    <p:spTree>
+      <p:nvGrpSpPr>
+        <p:cNvPr id="1" name=""/>
+        <p:cNvGrpSpPr/>
+        <p:nvPr/>
+      </p:nvGrpSpPr>
+      <p:grpSpPr>
+        <a:xfrm>
+          <a:off x="0" y="0"/>
+          <a:ext cx="0" cy="0"/>
+          <a:chOff x="0" y="0"/>
+          <a:chExt cx="0" cy="0"/>
+        </a:xfrm>
+      </p:grpSpPr>
+      <p:sp>
+        <p:nvSpPr>
+          <p:cNvPr id="2" name="Slide Image Placeholder 1"/>
+          <p:cNvSpPr>
+            <a:spLocks noGrp="1" noRot="1" noChangeAspect="1"/>
+          </p:cNvSpPr>
+          <p:nvPr>
+            <p:ph type="sldImg"/>
+          </p:nvPr>
+        </p:nvSpPr>
+        <p:spPr/>
+      </p:sp>
+      <p:sp>
+        <p:nvSpPr>
+          <p:cNvPr id="3" name="Notes Placeholder 2"/>
+          <p:cNvSpPr>
+            <a:spLocks noGrp="1"/>
+          </p:cNvSpPr>
+          <p:nvPr>
+            <p:ph type="body" idx="1"/>
+          </p:nvPr>
+        </p:nvSpPr>
+        <p:spPr/>
+        <p:txBody>
+          <a:bodyPr/>
+          <a:lstStyle/>
+          <a:p>
+            <a:r>
+              <a:rPr lang="en-US" dirty="0"/>
+              <a:t>SLIDE 11, 30 SECONDS.
+Every existing option fails at least one column. Coinbase and Crossmint
+custody the keys, full stop — not non-custodial, regulators and ToS become
+attack surfaces. Privy server wallets, same issue, Privy holds them. Safe is
+non-custodial but requires manual signing per action, which kills agent
+autonomy. We're the only row that hits all four: non-custodial via 7702,
+rich policy via the session-key validator, human escalation built into the
+flow, and AI-aware via the pluggable provider interface. The 7702-plus-
+session-key combo is the architectural unlock.</a:t>
+            </a:r>
+            <a:endParaRPr lang="en-US" dirty="0"/>
+          </a:p>
+        </p:txBody>
+      </p:sp>
+      <p:sp>
+        <p:nvSpPr>
+          <p:cNvPr id="4" name="Slide Number Placeholder 3"/>
+          <p:cNvSpPr>
+            <a:spLocks noGrp="1"/>
+          </p:cNvSpPr>
+          <p:nvPr>
+            <p:ph type="sldNum" sz="quarter" idx="10"/>
+          </p:nvPr>
+        </p:nvSpPr>
+        <p:spPr/>
+        <p:txBody>
+          <a:bodyPr/>
+          <a:lstStyle/>
+          <a:p>
+            <a:fld id="{F7021451-1387-4CA6-816F-3879F97B5CBC}" type="slidenum">
+              <a:rPr lang="en-US"/>
+              <a:t>11</a:t>
+            </a:fld>
+            <a:endParaRPr lang="en-US"/>
+          </a:p>
+        </p:txBody>
+      </p:sp>
+    </p:spTree>
+    <p:extLst>
+      <p:ext uri="{BB962C8B-B14F-4D97-AF65-F5344CB8AC3E}">
+        <p14:creationId xmlns:p14="http://schemas.microsoft.com/office/powerpoint/2010/main" val="1024086991"/>
+      </p:ext>
+    </p:extLst>
+  </p:cSld>
+  <p:clrMapOvr>
+    <a:masterClrMapping/>
+  </p:clrMapOvr>
+</p:notes>
+</file>
+
+<file path=ppt/notesSlides/notesSlide12.xml><?xml version="1.0" encoding="utf-8"?>
+<p:notes xmlns:a="http://schemas.openxmlformats.org/drawingml/2006/main" xmlns:r="http://schemas.openxmlformats.org/officeDocument/2006/relationships" xmlns:p="http://schemas.openxmlformats.org/presentationml/2006/main">
+  <p:cSld>
+    <p:spTree>
+      <p:nvGrpSpPr>
+        <p:cNvPr id="1" name=""/>
+        <p:cNvGrpSpPr/>
+        <p:nvPr/>
+      </p:nvGrpSpPr>
+      <p:grpSpPr>
+        <a:xfrm>
+          <a:off x="0" y="0"/>
+          <a:ext cx="0" cy="0"/>
+          <a:chOff x="0" y="0"/>
+          <a:chExt cx="0" cy="0"/>
+        </a:xfrm>
+      </p:grpSpPr>
+      <p:sp>
+        <p:nvSpPr>
+          <p:cNvPr id="2" name="Slide Image Placeholder 1"/>
+          <p:cNvSpPr>
+            <a:spLocks noGrp="1" noRot="1" noChangeAspect="1"/>
+          </p:cNvSpPr>
+          <p:nvPr>
+            <p:ph type="sldImg"/>
+          </p:nvPr>
+        </p:nvSpPr>
+        <p:spPr/>
+      </p:sp>
+      <p:sp>
+        <p:nvSpPr>
+          <p:cNvPr id="3" name="Notes Placeholder 2"/>
+          <p:cNvSpPr>
+            <a:spLocks noGrp="1"/>
+          </p:cNvSpPr>
+          <p:nvPr>
+            <p:ph type="body" idx="1"/>
+          </p:nvPr>
+        </p:nvSpPr>
+        <p:spPr/>
+        <p:txBody>
+          <a:bodyPr/>
+          <a:lstStyle/>
+          <a:p>
+            <a:r>
+              <a:rPr lang="en-US" dirty="0"/>
+              <a:t>SLIDE 12, 30 SECONDS.
+AI Guard is an interface, not a single engine. We ship two providers today.
+Developers add a vendor by adding one string to the config — that's the
+extension point. Lakera, Protect AI, Rebuff, Promptfoo all expose
+HTTP scanners we can wrap as a provider in an afternoon each. Revenue model
+is margin on those calls — we're the integration layer the developer
+already trusts, vendors get distribution, we take a cut per detection.
+Not a subscription, not a transaction fee. Marketplace dynamics: every new
+vendor we add makes every existing developer safer, every new developer
+makes the marketplace more attractive to vendors. That's the platform.</a:t>
+            </a:r>
+            <a:endParaRPr lang="en-US" dirty="0"/>
+          </a:p>
+        </p:txBody>
+      </p:sp>
+      <p:sp>
+        <p:nvSpPr>
+          <p:cNvPr id="4" name="Slide Number Placeholder 3"/>
+          <p:cNvSpPr>
+            <a:spLocks noGrp="1"/>
+          </p:cNvSpPr>
+          <p:nvPr>
+            <p:ph type="sldNum" sz="quarter" idx="10"/>
+          </p:nvPr>
+        </p:nvSpPr>
+        <p:spPr/>
+        <p:txBody>
+          <a:bodyPr/>
+          <a:lstStyle/>
+          <a:p>
+            <a:fld id="{F7021451-1387-4CA6-816F-3879F97B5CBC}" type="slidenum">
+              <a:rPr lang="en-US"/>
+              <a:t>12</a:t>
+            </a:fld>
+            <a:endParaRPr lang="en-US"/>
+          </a:p>
+        </p:txBody>
+      </p:sp>
+    </p:spTree>
+    <p:extLst>
+      <p:ext uri="{BB962C8B-B14F-4D97-AF65-F5344CB8AC3E}">
+        <p14:creationId xmlns:p14="http://schemas.microsoft.com/office/powerpoint/2010/main" val="1024086991"/>
+      </p:ext>
+    </p:extLst>
+  </p:cSld>
+  <p:clrMapOvr>
+    <a:masterClrMapping/>
+  </p:clrMapOvr>
+</p:notes>
+</file>
+
+<file path=ppt/notesSlides/notesSlide13.xml><?xml version="1.0" encoding="utf-8"?>
+<p:notes xmlns:a="http://schemas.openxmlformats.org/drawingml/2006/main" xmlns:r="http://schemas.openxmlformats.org/officeDocument/2006/relationships" xmlns:p="http://schemas.openxmlformats.org/presentationml/2006/main">
+  <p:cSld>
+    <p:spTree>
+      <p:nvGrpSpPr>
+        <p:cNvPr id="1" name=""/>
+        <p:cNvGrpSpPr/>
+        <p:nvPr/>
+      </p:nvGrpSpPr>
+      <p:grpSpPr>
+        <a:xfrm>
+          <a:off x="0" y="0"/>
+          <a:ext cx="0" cy="0"/>
+          <a:chOff x="0" y="0"/>
+          <a:chExt cx="0" cy="0"/>
+        </a:xfrm>
+      </p:grpSpPr>
+      <p:sp>
+        <p:nvSpPr>
+          <p:cNvPr id="2" name="Slide Image Placeholder 1"/>
+          <p:cNvSpPr>
+            <a:spLocks noGrp="1" noRot="1" noChangeAspect="1"/>
+          </p:cNvSpPr>
+          <p:nvPr>
+            <p:ph type="sldImg"/>
+          </p:nvPr>
+        </p:nvSpPr>
+        <p:spPr/>
+      </p:sp>
+      <p:sp>
+        <p:nvSpPr>
+          <p:cNvPr id="3" name="Notes Placeholder 2"/>
+          <p:cNvSpPr>
+            <a:spLocks noGrp="1"/>
+          </p:cNvSpPr>
+          <p:nvPr>
+            <p:ph type="body" idx="1"/>
+          </p:nvPr>
+        </p:nvSpPr>
+        <p:spPr/>
+        <p:txBody>
+          <a:bodyPr/>
+          <a:lstStyle/>
+          <a:p>
+            <a:r>
+              <a:rPr lang="en-US" dirty="0"/>
+              <a:t>SLIDE 13, 25 SECONDS.
+Every choice here was load-bearing for the demo. Privy TEE is what makes
+this non-custodial — we never see the owner key. 7702 plus Kernel v3.3 is
+what gives the user a smart account at the same address as their EOA, no
+funds migration, no UX cliff. ZeroDev Permissions API is what makes the
+on-chain caps actually EVM-enforced — three policy modules stacked on every
+session key. ZeroDev v3 bundler with paymaster means the user pays zero
+gas. Base Sepolia because 7702 is live, USDC is native, settlement is
+cheap. GPT-4o-mini is the workhorse for AI Guard — cheap enough to run
+on every call.</a:t>
+            </a:r>
+            <a:endParaRPr lang="en-US" dirty="0"/>
+          </a:p>
+        </p:txBody>
+      </p:sp>
+      <p:sp>
+        <p:nvSpPr>
+          <p:cNvPr id="4" name="Slide Number Placeholder 3"/>
+          <p:cNvSpPr>
+            <a:spLocks noGrp="1"/>
+          </p:cNvSpPr>
+          <p:nvPr>
+            <p:ph type="sldNum" sz="quarter" idx="10"/>
+          </p:nvPr>
+        </p:nvSpPr>
+        <p:spPr/>
+        <p:txBody>
+          <a:bodyPr/>
+          <a:lstStyle/>
+          <a:p>
+            <a:fld id="{F7021451-1387-4CA6-816F-3879F97B5CBC}" type="slidenum">
+              <a:rPr lang="en-US"/>
+              <a:t>13</a:t>
+            </a:fld>
+            <a:endParaRPr lang="en-US"/>
+          </a:p>
+        </p:txBody>
+      </p:sp>
+    </p:spTree>
+    <p:extLst>
+      <p:ext uri="{BB962C8B-B14F-4D97-AF65-F5344CB8AC3E}">
+        <p14:creationId xmlns:p14="http://schemas.microsoft.com/office/powerpoint/2010/main" val="1024086991"/>
+      </p:ext>
+    </p:extLst>
+  </p:cSld>
+  <p:clrMapOvr>
+    <a:masterClrMapping/>
+  </p:clrMapOvr>
+</p:notes>
+</file>
+
+<file path=ppt/notesSlides/notesSlide14.xml><?xml version="1.0" encoding="utf-8"?>
+<p:notes xmlns:a="http://schemas.openxmlformats.org/drawingml/2006/main" xmlns:r="http://schemas.openxmlformats.org/officeDocument/2006/relationships" xmlns:p="http://schemas.openxmlformats.org/presentationml/2006/main">
+  <p:cSld>
+    <p:spTree>
+      <p:nvGrpSpPr>
+        <p:cNvPr id="1" name=""/>
+        <p:cNvGrpSpPr/>
+        <p:nvPr/>
+      </p:nvGrpSpPr>
+      <p:grpSpPr>
+        <a:xfrm>
+          <a:off x="0" y="0"/>
+          <a:ext cx="0" cy="0"/>
+          <a:chOff x="0" y="0"/>
+          <a:chExt cx="0" cy="0"/>
+        </a:xfrm>
+      </p:grpSpPr>
+      <p:sp>
+        <p:nvSpPr>
+          <p:cNvPr id="2" name="Slide Image Placeholder 1"/>
+          <p:cNvSpPr>
+            <a:spLocks noGrp="1" noRot="1" noChangeAspect="1"/>
+          </p:cNvSpPr>
+          <p:nvPr>
+            <p:ph type="sldImg"/>
+          </p:nvPr>
+        </p:nvSpPr>
+        <p:spPr/>
+      </p:sp>
+      <p:sp>
+        <p:nvSpPr>
+          <p:cNvPr id="3" name="Notes Placeholder 2"/>
+          <p:cNvSpPr>
+            <a:spLocks noGrp="1"/>
+          </p:cNvSpPr>
+          <p:nvPr>
+            <p:ph type="body" idx="1"/>
+          </p:nvPr>
+        </p:nvSpPr>
+        <p:spPr/>
+        <p:txBody>
+          <a:bodyPr/>
+          <a:lstStyle/>
+          <a:p>
+            <a:r>
+              <a:rPr lang="en-US" dirty="0"/>
+              <a:t>SLIDE 14, 25 SECONDS.
+V3 is the obvious next layer — split the session key so a leak of one
+doesn't blow the larger cap. MPP — Tempo's new payments protocol — fits
+our session-key shape natively; we estimate half a day to MVP. Multi-chain
+unblocks as soon as 7702 plus ZeroDev support stabilizes on other L2s.
+And the premium providers are what turn this from infrastructure into a
+revenue engine. Crucially, none of these require a rewrite. They all
+extend the primitives we shipped this week.</a:t>
+            </a:r>
+            <a:endParaRPr lang="en-US" dirty="0"/>
+          </a:p>
+        </p:txBody>
+      </p:sp>
+      <p:sp>
+        <p:nvSpPr>
+          <p:cNvPr id="4" name="Slide Number Placeholder 3"/>
+          <p:cNvSpPr>
+            <a:spLocks noGrp="1"/>
+          </p:cNvSpPr>
+          <p:nvPr>
+            <p:ph type="sldNum" sz="quarter" idx="10"/>
+          </p:nvPr>
+        </p:nvSpPr>
+        <p:spPr/>
+        <p:txBody>
+          <a:bodyPr/>
+          <a:lstStyle/>
+          <a:p>
+            <a:fld id="{F7021451-1387-4CA6-816F-3879F97B5CBC}" type="slidenum">
+              <a:rPr lang="en-US"/>
+              <a:t>14</a:t>
+            </a:fld>
+            <a:endParaRPr lang="en-US"/>
+          </a:p>
+        </p:txBody>
+      </p:sp>
+    </p:spTree>
+    <p:extLst>
+      <p:ext uri="{BB962C8B-B14F-4D97-AF65-F5344CB8AC3E}">
+        <p14:creationId xmlns:p14="http://schemas.microsoft.com/office/powerpoint/2010/main" val="1024086991"/>
+      </p:ext>
+    </p:extLst>
+  </p:cSld>
+  <p:clrMapOvr>
+    <a:masterClrMapping/>
+  </p:clrMapOvr>
+</p:notes>
+</file>
+
+<file path=ppt/notesSlides/notesSlide15.xml><?xml version="1.0" encoding="utf-8"?>
+<p:notes xmlns:a="http://schemas.openxmlformats.org/drawingml/2006/main" xmlns:r="http://schemas.openxmlformats.org/officeDocument/2006/relationships" xmlns:p="http://schemas.openxmlformats.org/presentationml/2006/main">
+  <p:cSld>
+    <p:spTree>
+      <p:nvGrpSpPr>
+        <p:cNvPr id="1" name=""/>
+        <p:cNvGrpSpPr/>
+        <p:nvPr/>
+      </p:nvGrpSpPr>
+      <p:grpSpPr>
+        <a:xfrm>
+          <a:off x="0" y="0"/>
+          <a:ext cx="0" cy="0"/>
+          <a:chOff x="0" y="0"/>
+          <a:chExt cx="0" cy="0"/>
+        </a:xfrm>
+      </p:grpSpPr>
+      <p:sp>
+        <p:nvSpPr>
+          <p:cNvPr id="2" name="Slide Image Placeholder 1"/>
+          <p:cNvSpPr>
+            <a:spLocks noGrp="1" noRot="1" noChangeAspect="1"/>
+          </p:cNvSpPr>
+          <p:nvPr>
+            <p:ph type="sldImg"/>
+          </p:nvPr>
+        </p:nvSpPr>
+        <p:spPr/>
+      </p:sp>
+      <p:sp>
+        <p:nvSpPr>
+          <p:cNvPr id="3" name="Notes Placeholder 2"/>
+          <p:cNvSpPr>
+            <a:spLocks noGrp="1"/>
+          </p:cNvSpPr>
+          <p:nvPr>
+            <p:ph type="body" idx="1"/>
+          </p:nvPr>
+        </p:nvSpPr>
+        <p:spPr/>
+        <p:txBody>
+          <a:bodyPr/>
+          <a:lstStyle/>
+          <a:p>
+            <a:r>
+              <a:rPr lang="en-US" dirty="0"/>
+              <a:t>SLIDE 15, 20 SECONDS.
+Repo, live demo, and we're applying to Privy, ZeroDev, Base, and OpenAI
+sponsor tracks — this product sits across all four. We'd love follow-ups
+with anyone building agent infra. Thanks.</a:t>
+            </a:r>
+            <a:endParaRPr lang="en-US" dirty="0"/>
+          </a:p>
+        </p:txBody>
+      </p:sp>
+      <p:sp>
+        <p:nvSpPr>
+          <p:cNvPr id="4" name="Slide Number Placeholder 3"/>
+          <p:cNvSpPr>
+            <a:spLocks noGrp="1"/>
+          </p:cNvSpPr>
+          <p:nvPr>
+            <p:ph type="sldNum" sz="quarter" idx="10"/>
+          </p:nvPr>
+        </p:nvSpPr>
+        <p:spPr/>
+        <p:txBody>
+          <a:bodyPr/>
+          <a:lstStyle/>
+          <a:p>
+            <a:fld id="{F7021451-1387-4CA6-816F-3879F97B5CBC}" type="slidenum">
+              <a:rPr lang="en-US"/>
+              <a:t>15</a:t>
             </a:fld>
             <a:endParaRPr lang="en-US"/>
           </a:p>
@@ -1753,6 +2235,201 @@
 <file path=ppt/slides/slide10.xml><?xml version="1.0" encoding="utf-8"?>
 <p:sld xmlns:a="http://schemas.openxmlformats.org/drawingml/2006/main" xmlns:r="http://schemas.openxmlformats.org/officeDocument/2006/relationships" xmlns:p="http://schemas.openxmlformats.org/presentationml/2006/main">
   <p:cSld name="Slide 10">
+    <p:bg>
+      <p:bgPr>
+        <a:blipFill dpi="0" rotWithShape="1">
+          <a:blip r:embed="rId1">
+            <a:lum/>
+          </a:blip>
+          <a:srcRect/>
+          <a:stretch>
+            <a:fillRect/>
+          </a:stretch>
+        </a:blipFill>
+        <a:effectLst/>
+      </p:bgPr>
+    </p:bg>
+    <p:spTree>
+      <p:nvGrpSpPr>
+        <p:cNvPr id="1" name=""/>
+        <p:cNvGrpSpPr/>
+        <p:nvPr/>
+      </p:nvGrpSpPr>
+      <p:grpSpPr>
+        <a:xfrm>
+          <a:off x="0" y="0"/>
+          <a:ext cx="0" cy="0"/>
+          <a:chOff x="0" y="0"/>
+          <a:chExt cx="0" cy="0"/>
+        </a:xfrm>
+      </p:grpSpPr>
+    </p:spTree>
+  </p:cSld>
+  <p:clrMapOvr>
+    <a:masterClrMapping/>
+  </p:clrMapOvr>
+</p:sld>
+</file>
+
+<file path=ppt/slides/slide11.xml><?xml version="1.0" encoding="utf-8"?>
+<p:sld xmlns:a="http://schemas.openxmlformats.org/drawingml/2006/main" xmlns:r="http://schemas.openxmlformats.org/officeDocument/2006/relationships" xmlns:p="http://schemas.openxmlformats.org/presentationml/2006/main">
+  <p:cSld name="Slide 11">
+    <p:bg>
+      <p:bgPr>
+        <a:blipFill dpi="0" rotWithShape="1">
+          <a:blip r:embed="rId1">
+            <a:lum/>
+          </a:blip>
+          <a:srcRect/>
+          <a:stretch>
+            <a:fillRect/>
+          </a:stretch>
+        </a:blipFill>
+        <a:effectLst/>
+      </p:bgPr>
+    </p:bg>
+    <p:spTree>
+      <p:nvGrpSpPr>
+        <p:cNvPr id="1" name=""/>
+        <p:cNvGrpSpPr/>
+        <p:nvPr/>
+      </p:nvGrpSpPr>
+      <p:grpSpPr>
+        <a:xfrm>
+          <a:off x="0" y="0"/>
+          <a:ext cx="0" cy="0"/>
+          <a:chOff x="0" y="0"/>
+          <a:chExt cx="0" cy="0"/>
+        </a:xfrm>
+      </p:grpSpPr>
+    </p:spTree>
+  </p:cSld>
+  <p:clrMapOvr>
+    <a:masterClrMapping/>
+  </p:clrMapOvr>
+</p:sld>
+</file>
+
+<file path=ppt/slides/slide12.xml><?xml version="1.0" encoding="utf-8"?>
+<p:sld xmlns:a="http://schemas.openxmlformats.org/drawingml/2006/main" xmlns:r="http://schemas.openxmlformats.org/officeDocument/2006/relationships" xmlns:p="http://schemas.openxmlformats.org/presentationml/2006/main">
+  <p:cSld name="Slide 12">
+    <p:bg>
+      <p:bgPr>
+        <a:blipFill dpi="0" rotWithShape="1">
+          <a:blip r:embed="rId1">
+            <a:lum/>
+          </a:blip>
+          <a:srcRect/>
+          <a:stretch>
+            <a:fillRect/>
+          </a:stretch>
+        </a:blipFill>
+        <a:effectLst/>
+      </p:bgPr>
+    </p:bg>
+    <p:spTree>
+      <p:nvGrpSpPr>
+        <p:cNvPr id="1" name=""/>
+        <p:cNvGrpSpPr/>
+        <p:nvPr/>
+      </p:nvGrpSpPr>
+      <p:grpSpPr>
+        <a:xfrm>
+          <a:off x="0" y="0"/>
+          <a:ext cx="0" cy="0"/>
+          <a:chOff x="0" y="0"/>
+          <a:chExt cx="0" cy="0"/>
+        </a:xfrm>
+      </p:grpSpPr>
+    </p:spTree>
+  </p:cSld>
+  <p:clrMapOvr>
+    <a:masterClrMapping/>
+  </p:clrMapOvr>
+</p:sld>
+</file>
+
+<file path=ppt/slides/slide13.xml><?xml version="1.0" encoding="utf-8"?>
+<p:sld xmlns:a="http://schemas.openxmlformats.org/drawingml/2006/main" xmlns:r="http://schemas.openxmlformats.org/officeDocument/2006/relationships" xmlns:p="http://schemas.openxmlformats.org/presentationml/2006/main">
+  <p:cSld name="Slide 13">
+    <p:bg>
+      <p:bgPr>
+        <a:blipFill dpi="0" rotWithShape="1">
+          <a:blip r:embed="rId1">
+            <a:lum/>
+          </a:blip>
+          <a:srcRect/>
+          <a:stretch>
+            <a:fillRect/>
+          </a:stretch>
+        </a:blipFill>
+        <a:effectLst/>
+      </p:bgPr>
+    </p:bg>
+    <p:spTree>
+      <p:nvGrpSpPr>
+        <p:cNvPr id="1" name=""/>
+        <p:cNvGrpSpPr/>
+        <p:nvPr/>
+      </p:nvGrpSpPr>
+      <p:grpSpPr>
+        <a:xfrm>
+          <a:off x="0" y="0"/>
+          <a:ext cx="0" cy="0"/>
+          <a:chOff x="0" y="0"/>
+          <a:chExt cx="0" cy="0"/>
+        </a:xfrm>
+      </p:grpSpPr>
+    </p:spTree>
+  </p:cSld>
+  <p:clrMapOvr>
+    <a:masterClrMapping/>
+  </p:clrMapOvr>
+</p:sld>
+</file>
+
+<file path=ppt/slides/slide14.xml><?xml version="1.0" encoding="utf-8"?>
+<p:sld xmlns:a="http://schemas.openxmlformats.org/drawingml/2006/main" xmlns:r="http://schemas.openxmlformats.org/officeDocument/2006/relationships" xmlns:p="http://schemas.openxmlformats.org/presentationml/2006/main">
+  <p:cSld name="Slide 14">
+    <p:bg>
+      <p:bgPr>
+        <a:blipFill dpi="0" rotWithShape="1">
+          <a:blip r:embed="rId1">
+            <a:lum/>
+          </a:blip>
+          <a:srcRect/>
+          <a:stretch>
+            <a:fillRect/>
+          </a:stretch>
+        </a:blipFill>
+        <a:effectLst/>
+      </p:bgPr>
+    </p:bg>
+    <p:spTree>
+      <p:nvGrpSpPr>
+        <p:cNvPr id="1" name=""/>
+        <p:cNvGrpSpPr/>
+        <p:nvPr/>
+      </p:nvGrpSpPr>
+      <p:grpSpPr>
+        <a:xfrm>
+          <a:off x="0" y="0"/>
+          <a:ext cx="0" cy="0"/>
+          <a:chOff x="0" y="0"/>
+          <a:chExt cx="0" cy="0"/>
+        </a:xfrm>
+      </p:grpSpPr>
+    </p:spTree>
+  </p:cSld>
+  <p:clrMapOvr>
+    <a:masterClrMapping/>
+  </p:clrMapOvr>
+</p:sld>
+</file>
+
+<file path=ppt/slides/slide15.xml><?xml version="1.0" encoding="utf-8"?>
+<p:sld xmlns:a="http://schemas.openxmlformats.org/drawingml/2006/main" xmlns:r="http://schemas.openxmlformats.org/officeDocument/2006/relationships" xmlns:p="http://schemas.openxmlformats.org/presentationml/2006/main">
+  <p:cSld name="Slide 15">
     <p:bg>
       <p:bgPr>
         <a:blipFill dpi="0" rotWithShape="1">

</xml_diff>

<commit_message>
docs: refocus pitch deck on problem + safety promises, demote tech to appendix
Restructure around three plain-English safety promises ("even if X breaks,
you're safe because Y") instead of five mechanism slides. Add a concrete
prompt-injection attack walkthrough so the problem lands viscerally.
Move architecture + tech stack to appendix.

Co-Authored-By: Claude Opus 4.7 (1M context) <noreply@anthropic.com>
</commit_message>
<xml_diff>
--- a/docs/PITCH-DECK.pptx
+++ b/docs/PITCH-DECK.pptx
@@ -609,102 +609,6 @@
             <a:r>
               <a:rPr lang="en-US" dirty="0"/>
               <a:t>SLIDE 10, 30 SECONDS.
-This is what's running today, not what's planned. Onboarding takes 30 seconds
-and ends with an API key the developer pastes into their agent. Policy editor
-hot-reloads. AI Guard catches intent drift live in the demo. Three execution
-tiers all wire into a single SDK call — the developer just awaits, the
-status field tells them which path was taken. x402 settles in about four
-seconds, which is the unit-economics number for micropayments. Emergency
-Stop is one Privy popup that sweeps the account and revokes the key in
-five seconds. Live URL is at the bottom — judges can sign up themselves.</a:t>
-            </a:r>
-            <a:endParaRPr lang="en-US" dirty="0"/>
-          </a:p>
-        </p:txBody>
-      </p:sp>
-      <p:sp>
-        <p:nvSpPr>
-          <p:cNvPr id="4" name="Slide Number Placeholder 3"/>
-          <p:cNvSpPr>
-            <a:spLocks noGrp="1"/>
-          </p:cNvSpPr>
-          <p:nvPr>
-            <p:ph type="sldNum" sz="quarter" idx="10"/>
-          </p:nvPr>
-        </p:nvSpPr>
-        <p:spPr/>
-        <p:txBody>
-          <a:bodyPr/>
-          <a:lstStyle/>
-          <a:p>
-            <a:fld id="{F7021451-1387-4CA6-816F-3879F97B5CBC}" type="slidenum">
-              <a:rPr lang="en-US"/>
-              <a:t>10</a:t>
-            </a:fld>
-            <a:endParaRPr lang="en-US"/>
-          </a:p>
-        </p:txBody>
-      </p:sp>
-    </p:spTree>
-    <p:extLst>
-      <p:ext uri="{BB962C8B-B14F-4D97-AF65-F5344CB8AC3E}">
-        <p14:creationId xmlns:p14="http://schemas.microsoft.com/office/powerpoint/2010/main" val="1024086991"/>
-      </p:ext>
-    </p:extLst>
-  </p:cSld>
-  <p:clrMapOvr>
-    <a:masterClrMapping/>
-  </p:clrMapOvr>
-</p:notes>
-</file>
-
-<file path=ppt/notesSlides/notesSlide11.xml><?xml version="1.0" encoding="utf-8"?>
-<p:notes xmlns:a="http://schemas.openxmlformats.org/drawingml/2006/main" xmlns:r="http://schemas.openxmlformats.org/officeDocument/2006/relationships" xmlns:p="http://schemas.openxmlformats.org/presentationml/2006/main">
-  <p:cSld>
-    <p:spTree>
-      <p:nvGrpSpPr>
-        <p:cNvPr id="1" name=""/>
-        <p:cNvGrpSpPr/>
-        <p:nvPr/>
-      </p:nvGrpSpPr>
-      <p:grpSpPr>
-        <a:xfrm>
-          <a:off x="0" y="0"/>
-          <a:ext cx="0" cy="0"/>
-          <a:chOff x="0" y="0"/>
-          <a:chExt cx="0" cy="0"/>
-        </a:xfrm>
-      </p:grpSpPr>
-      <p:sp>
-        <p:nvSpPr>
-          <p:cNvPr id="2" name="Slide Image Placeholder 1"/>
-          <p:cNvSpPr>
-            <a:spLocks noGrp="1" noRot="1" noChangeAspect="1"/>
-          </p:cNvSpPr>
-          <p:nvPr>
-            <p:ph type="sldImg"/>
-          </p:nvPr>
-        </p:nvSpPr>
-        <p:spPr/>
-      </p:sp>
-      <p:sp>
-        <p:nvSpPr>
-          <p:cNvPr id="3" name="Notes Placeholder 2"/>
-          <p:cNvSpPr>
-            <a:spLocks noGrp="1"/>
-          </p:cNvSpPr>
-          <p:nvPr>
-            <p:ph type="body" idx="1"/>
-          </p:nvPr>
-        </p:nvSpPr>
-        <p:spPr/>
-        <p:txBody>
-          <a:bodyPr/>
-          <a:lstStyle/>
-          <a:p>
-            <a:r>
-              <a:rPr lang="en-US" dirty="0"/>
-              <a:t>SLIDE 11, 30 SECONDS.
 Every existing option fails at least one column. Coinbase and Crossmint
 custody the keys, full stop — not non-custodial, regulators and ToS become
 attack surfaces. Privy server wallets, same issue, Privy holds them. Safe is
@@ -735,7 +639,7 @@
           <a:p>
             <a:fld id="{F7021451-1387-4CA6-816F-3879F97B5CBC}" type="slidenum">
               <a:rPr lang="en-US"/>
-              <a:t>11</a:t>
+              <a:t>10</a:t>
             </a:fld>
             <a:endParaRPr lang="en-US"/>
           </a:p>
@@ -754,7 +658,7 @@
 </p:notes>
 </file>
 
-<file path=ppt/notesSlides/notesSlide12.xml><?xml version="1.0" encoding="utf-8"?>
+<file path=ppt/notesSlides/notesSlide11.xml><?xml version="1.0" encoding="utf-8"?>
 <p:notes xmlns:a="http://schemas.openxmlformats.org/drawingml/2006/main" xmlns:r="http://schemas.openxmlformats.org/officeDocument/2006/relationships" xmlns:p="http://schemas.openxmlformats.org/presentationml/2006/main">
   <p:cSld>
     <p:spTree>
@@ -800,7 +704,7 @@
           <a:p>
             <a:r>
               <a:rPr lang="en-US" dirty="0"/>
-              <a:t>SLIDE 12, 30 SECONDS.
+              <a:t>SLIDE 11, 30 SECONDS.
 AI Guard is an interface, not a single engine. We ship two providers today.
 Developers add a vendor by adding one string to the config — that's the
 extension point. Lakera, Protect AI, Rebuff, Promptfoo all expose
@@ -832,7 +736,7 @@
           <a:p>
             <a:fld id="{F7021451-1387-4CA6-816F-3879F97B5CBC}" type="slidenum">
               <a:rPr lang="en-US"/>
-              <a:t>12</a:t>
+              <a:t>11</a:t>
             </a:fld>
             <a:endParaRPr lang="en-US"/>
           </a:p>
@@ -851,7 +755,7 @@
 </p:notes>
 </file>
 
-<file path=ppt/notesSlides/notesSlide13.xml><?xml version="1.0" encoding="utf-8"?>
+<file path=ppt/notesSlides/notesSlide12.xml><?xml version="1.0" encoding="utf-8"?>
 <p:notes xmlns:a="http://schemas.openxmlformats.org/drawingml/2006/main" xmlns:r="http://schemas.openxmlformats.org/officeDocument/2006/relationships" xmlns:p="http://schemas.openxmlformats.org/presentationml/2006/main">
   <p:cSld>
     <p:spTree>
@@ -897,104 +801,7 @@
           <a:p>
             <a:r>
               <a:rPr lang="en-US" dirty="0"/>
-              <a:t>SLIDE 13, 25 SECONDS.
-Every choice here was load-bearing for the demo. Privy TEE is what makes
-this non-custodial — we never see the owner key. 7702 plus Kernel v3.3 is
-what gives the user a smart account at the same address as their EOA, no
-funds migration, no UX cliff. ZeroDev Permissions API is what makes the
-on-chain caps actually EVM-enforced — three policy modules stacked on every
-session key. ZeroDev v3 bundler with paymaster means the user pays zero
-gas. Base Sepolia because 7702 is live, USDC is native, settlement is
-cheap. GPT-4o-mini is the workhorse for AI Guard — cheap enough to run
-on every call.</a:t>
-            </a:r>
-            <a:endParaRPr lang="en-US" dirty="0"/>
-          </a:p>
-        </p:txBody>
-      </p:sp>
-      <p:sp>
-        <p:nvSpPr>
-          <p:cNvPr id="4" name="Slide Number Placeholder 3"/>
-          <p:cNvSpPr>
-            <a:spLocks noGrp="1"/>
-          </p:cNvSpPr>
-          <p:nvPr>
-            <p:ph type="sldNum" sz="quarter" idx="10"/>
-          </p:nvPr>
-        </p:nvSpPr>
-        <p:spPr/>
-        <p:txBody>
-          <a:bodyPr/>
-          <a:lstStyle/>
-          <a:p>
-            <a:fld id="{F7021451-1387-4CA6-816F-3879F97B5CBC}" type="slidenum">
-              <a:rPr lang="en-US"/>
-              <a:t>13</a:t>
-            </a:fld>
-            <a:endParaRPr lang="en-US"/>
-          </a:p>
-        </p:txBody>
-      </p:sp>
-    </p:spTree>
-    <p:extLst>
-      <p:ext uri="{BB962C8B-B14F-4D97-AF65-F5344CB8AC3E}">
-        <p14:creationId xmlns:p14="http://schemas.microsoft.com/office/powerpoint/2010/main" val="1024086991"/>
-      </p:ext>
-    </p:extLst>
-  </p:cSld>
-  <p:clrMapOvr>
-    <a:masterClrMapping/>
-  </p:clrMapOvr>
-</p:notes>
-</file>
-
-<file path=ppt/notesSlides/notesSlide14.xml><?xml version="1.0" encoding="utf-8"?>
-<p:notes xmlns:a="http://schemas.openxmlformats.org/drawingml/2006/main" xmlns:r="http://schemas.openxmlformats.org/officeDocument/2006/relationships" xmlns:p="http://schemas.openxmlformats.org/presentationml/2006/main">
-  <p:cSld>
-    <p:spTree>
-      <p:nvGrpSpPr>
-        <p:cNvPr id="1" name=""/>
-        <p:cNvGrpSpPr/>
-        <p:nvPr/>
-      </p:nvGrpSpPr>
-      <p:grpSpPr>
-        <a:xfrm>
-          <a:off x="0" y="0"/>
-          <a:ext cx="0" cy="0"/>
-          <a:chOff x="0" y="0"/>
-          <a:chExt cx="0" cy="0"/>
-        </a:xfrm>
-      </p:grpSpPr>
-      <p:sp>
-        <p:nvSpPr>
-          <p:cNvPr id="2" name="Slide Image Placeholder 1"/>
-          <p:cNvSpPr>
-            <a:spLocks noGrp="1" noRot="1" noChangeAspect="1"/>
-          </p:cNvSpPr>
-          <p:nvPr>
-            <p:ph type="sldImg"/>
-          </p:nvPr>
-        </p:nvSpPr>
-        <p:spPr/>
-      </p:sp>
-      <p:sp>
-        <p:nvSpPr>
-          <p:cNvPr id="3" name="Notes Placeholder 2"/>
-          <p:cNvSpPr>
-            <a:spLocks noGrp="1"/>
-          </p:cNvSpPr>
-          <p:nvPr>
-            <p:ph type="body" idx="1"/>
-          </p:nvPr>
-        </p:nvSpPr>
-        <p:spPr/>
-        <p:txBody>
-          <a:bodyPr/>
-          <a:lstStyle/>
-          <a:p>
-            <a:r>
-              <a:rPr lang="en-US" dirty="0"/>
-              <a:t>SLIDE 14, 25 SECONDS.
+              <a:t>SLIDE 12, 25 SECONDS.
 V3 is the obvious next layer — split the session key so a leak of one
 doesn't blow the larger cap. MPP — Tempo's new payments protocol — fits
 our session-key shape natively; we estimate half a day to MVP. Multi-chain
@@ -1024,7 +831,7 @@
           <a:p>
             <a:fld id="{F7021451-1387-4CA6-816F-3879F97B5CBC}" type="slidenum">
               <a:rPr lang="en-US"/>
-              <a:t>14</a:t>
+              <a:t>12</a:t>
             </a:fld>
             <a:endParaRPr lang="en-US"/>
           </a:p>
@@ -1043,7 +850,7 @@
 </p:notes>
 </file>
 
-<file path=ppt/notesSlides/notesSlide15.xml><?xml version="1.0" encoding="utf-8"?>
+<file path=ppt/notesSlides/notesSlide13.xml><?xml version="1.0" encoding="utf-8"?>
 <p:notes xmlns:a="http://schemas.openxmlformats.org/drawingml/2006/main" xmlns:r="http://schemas.openxmlformats.org/officeDocument/2006/relationships" xmlns:p="http://schemas.openxmlformats.org/presentationml/2006/main">
   <p:cSld>
     <p:spTree>
@@ -1089,7 +896,7 @@
           <a:p>
             <a:r>
               <a:rPr lang="en-US" dirty="0"/>
-              <a:t>SLIDE 15, 20 SECONDS.
+              <a:t>SLIDE 13, 20 SECONDS.
 Repo, live demo, and we're applying to Privy, ZeroDev, Base, and OpenAI
 sponsor tracks — this product sits across all four. We'd love follow-ups
 with anyone building agent infra. Thanks.</a:t>
@@ -1115,7 +922,7 @@
           <a:p>
             <a:fld id="{F7021451-1387-4CA6-816F-3879F97B5CBC}" type="slidenum">
               <a:rPr lang="en-US"/>
-              <a:t>15</a:t>
+              <a:t>13</a:t>
             </a:fld>
             <a:endParaRPr lang="en-US"/>
           </a:p>
@@ -1134,6 +941,196 @@
 </p:notes>
 </file>
 
+<file path=ppt/notesSlides/notesSlide14.xml><?xml version="1.0" encoding="utf-8"?>
+<p:notes xmlns:a="http://schemas.openxmlformats.org/drawingml/2006/main" xmlns:r="http://schemas.openxmlformats.org/officeDocument/2006/relationships" xmlns:p="http://schemas.openxmlformats.org/presentationml/2006/main">
+  <p:cSld>
+    <p:spTree>
+      <p:nvGrpSpPr>
+        <p:cNvPr id="1" name=""/>
+        <p:cNvGrpSpPr/>
+        <p:nvPr/>
+      </p:nvGrpSpPr>
+      <p:grpSpPr>
+        <a:xfrm>
+          <a:off x="0" y="0"/>
+          <a:ext cx="0" cy="0"/>
+          <a:chOff x="0" y="0"/>
+          <a:chExt cx="0" cy="0"/>
+        </a:xfrm>
+      </p:grpSpPr>
+      <p:sp>
+        <p:nvSpPr>
+          <p:cNvPr id="2" name="Slide Image Placeholder 1"/>
+          <p:cNvSpPr>
+            <a:spLocks noGrp="1" noRot="1" noChangeAspect="1"/>
+          </p:cNvSpPr>
+          <p:nvPr>
+            <p:ph type="sldImg"/>
+          </p:nvPr>
+        </p:nvSpPr>
+        <p:spPr/>
+      </p:sp>
+      <p:sp>
+        <p:nvSpPr>
+          <p:cNvPr id="3" name="Notes Placeholder 2"/>
+          <p:cNvSpPr>
+            <a:spLocks noGrp="1"/>
+          </p:cNvSpPr>
+          <p:nvPr>
+            <p:ph type="body" idx="1"/>
+          </p:nvPr>
+        </p:nvSpPr>
+        <p:spPr/>
+        <p:txBody>
+          <a:bodyPr/>
+          <a:lstStyle/>
+          <a:p>
+            <a:r>
+              <a:rPr lang="en-US" dirty="0"/>
+              <a:t>APPENDIX 1, ON DEMAND.
+For judges who want the wiring. The SDK is the single API surface. Inside
+the backend, the policy engine is the off-chain layer, AI Guard runs intent
+diff and injection scanners. The tier router decides whether a UserOp goes
+out via the session key (AUTO/GUARD) or escalates to the owner key
+(HUMAN). The smart account has two validators — V1 Owner via Privy TEE,
+V2 Agent session key with the on-chain caps. Privy for identity, EIP-7702
+for in-place EOA upgrade, ZeroDev for the validator modules.</a:t>
+            </a:r>
+            <a:endParaRPr lang="en-US" dirty="0"/>
+          </a:p>
+        </p:txBody>
+      </p:sp>
+      <p:sp>
+        <p:nvSpPr>
+          <p:cNvPr id="4" name="Slide Number Placeholder 3"/>
+          <p:cNvSpPr>
+            <a:spLocks noGrp="1"/>
+          </p:cNvSpPr>
+          <p:nvPr>
+            <p:ph type="sldNum" sz="quarter" idx="10"/>
+          </p:nvPr>
+        </p:nvSpPr>
+        <p:spPr/>
+        <p:txBody>
+          <a:bodyPr/>
+          <a:lstStyle/>
+          <a:p>
+            <a:fld id="{F7021451-1387-4CA6-816F-3879F97B5CBC}" type="slidenum">
+              <a:rPr lang="en-US"/>
+              <a:t>14</a:t>
+            </a:fld>
+            <a:endParaRPr lang="en-US"/>
+          </a:p>
+        </p:txBody>
+      </p:sp>
+    </p:spTree>
+    <p:extLst>
+      <p:ext uri="{BB962C8B-B14F-4D97-AF65-F5344CB8AC3E}">
+        <p14:creationId xmlns:p14="http://schemas.microsoft.com/office/powerpoint/2010/main" val="1024086991"/>
+      </p:ext>
+    </p:extLst>
+  </p:cSld>
+  <p:clrMapOvr>
+    <a:masterClrMapping/>
+  </p:clrMapOvr>
+</p:notes>
+</file>
+
+<file path=ppt/notesSlides/notesSlide15.xml><?xml version="1.0" encoding="utf-8"?>
+<p:notes xmlns:a="http://schemas.openxmlformats.org/drawingml/2006/main" xmlns:r="http://schemas.openxmlformats.org/officeDocument/2006/relationships" xmlns:p="http://schemas.openxmlformats.org/presentationml/2006/main">
+  <p:cSld>
+    <p:spTree>
+      <p:nvGrpSpPr>
+        <p:cNvPr id="1" name=""/>
+        <p:cNvGrpSpPr/>
+        <p:nvPr/>
+      </p:nvGrpSpPr>
+      <p:grpSpPr>
+        <a:xfrm>
+          <a:off x="0" y="0"/>
+          <a:ext cx="0" cy="0"/>
+          <a:chOff x="0" y="0"/>
+          <a:chExt cx="0" cy="0"/>
+        </a:xfrm>
+      </p:grpSpPr>
+      <p:sp>
+        <p:nvSpPr>
+          <p:cNvPr id="2" name="Slide Image Placeholder 1"/>
+          <p:cNvSpPr>
+            <a:spLocks noGrp="1" noRot="1" noChangeAspect="1"/>
+          </p:cNvSpPr>
+          <p:nvPr>
+            <p:ph type="sldImg"/>
+          </p:nvPr>
+        </p:nvSpPr>
+        <p:spPr/>
+      </p:sp>
+      <p:sp>
+        <p:nvSpPr>
+          <p:cNvPr id="3" name="Notes Placeholder 2"/>
+          <p:cNvSpPr>
+            <a:spLocks noGrp="1"/>
+          </p:cNvSpPr>
+          <p:nvPr>
+            <p:ph type="body" idx="1"/>
+          </p:nvPr>
+        </p:nvSpPr>
+        <p:spPr/>
+        <p:txBody>
+          <a:bodyPr/>
+          <a:lstStyle/>
+          <a:p>
+            <a:r>
+              <a:rPr lang="en-US" dirty="0"/>
+              <a:t>APPENDIX 2, ON DEMAND.
+Every choice is load-bearing. Privy TEE is what makes the owner-key story
+non-custodial. EIP-7702 plus Kernel v3.3 gives the same address before
+and after upgrade — no migration UX cliff. ZeroDev Permissions API is what
+makes the on-chain cap EVM-enforced rather than backend-promised. ZeroDev
+v3 bundler with paymaster means zero user gas. Base Sepolia because 7702
+is live and USDC is native. GPT-4o-mini is cheap enough to scan every
+signature.</a:t>
+            </a:r>
+            <a:endParaRPr lang="en-US" dirty="0"/>
+          </a:p>
+        </p:txBody>
+      </p:sp>
+      <p:sp>
+        <p:nvSpPr>
+          <p:cNvPr id="4" name="Slide Number Placeholder 3"/>
+          <p:cNvSpPr>
+            <a:spLocks noGrp="1"/>
+          </p:cNvSpPr>
+          <p:nvPr>
+            <p:ph type="sldNum" sz="quarter" idx="10"/>
+          </p:nvPr>
+        </p:nvSpPr>
+        <p:spPr/>
+        <p:txBody>
+          <a:bodyPr/>
+          <a:lstStyle/>
+          <a:p>
+            <a:fld id="{F7021451-1387-4CA6-816F-3879F97B5CBC}" type="slidenum">
+              <a:rPr lang="en-US"/>
+              <a:t>15</a:t>
+            </a:fld>
+            <a:endParaRPr lang="en-US"/>
+          </a:p>
+        </p:txBody>
+      </p:sp>
+    </p:spTree>
+    <p:extLst>
+      <p:ext uri="{BB962C8B-B14F-4D97-AF65-F5344CB8AC3E}">
+        <p14:creationId xmlns:p14="http://schemas.microsoft.com/office/powerpoint/2010/main" val="1024086991"/>
+      </p:ext>
+    </p:extLst>
+  </p:cSld>
+  <p:clrMapOvr>
+    <a:masterClrMapping/>
+  </p:clrMapOvr>
+</p:notes>
+</file>
+
 <file path=ppt/notesSlides/notesSlide2.xml><?xml version="1.0" encoding="utf-8"?>
 <p:notes xmlns:a="http://schemas.openxmlformats.org/drawingml/2006/main" xmlns:r="http://schemas.openxmlformats.org/officeDocument/2006/relationships" xmlns:p="http://schemas.openxmlformats.org/presentationml/2006/main">
   <p:cSld>
@@ -1180,11 +1177,13 @@
           <a:p>
             <a:r>
               <a:rPr lang="en-US" dirty="0"/>
-              <a:t>SLIDE 2, 20 SECONDS.
-Coinbase CDP, Crossmint — fully custodial. They hold your keys.
-Or you go raw EOA, one private key in an env var, and the first malicious
-prompt empties the account. No one has solved the middle: agents that act
-autonomously without anyone holding ultimate authority over the funds.</a:t>
+              <a:t>SLIDE 2, 25 SECONDS.
+Right now, if you're shipping an AI agent that touches money, you have
+two doors. Door one: hand a custodian your keys. Coinbase CDP, Crossmint —
+fully custodial. Their terms of service, their compliance posture, their
+exit risk are now yours. Door two: stuff a raw private key into a dotenv,
+let the agent sign with it. One malicious prompt empties the account.
+Nobody has built the middle.</a:t>
             </a:r>
             <a:endParaRPr lang="en-US" dirty="0"/>
           </a:p>
@@ -1272,12 +1271,13 @@
           <a:p>
             <a:r>
               <a:rPr lang="en-US" dirty="0"/>
-              <a:t>SLIDE 3, 20 SECONDS.
-Five things. One — single API, one line. Two — on-chain guard, the EVM
-enforces the cap, not us. Three — off-chain policy engine. Four — AI guard
-for the threats only agents face. Five — human approval for anything
-anomalous. The unifying theme: one config object, every knob configurable,
-and the defaults are safe.</a:t>
+              <a:t>SLIDE 3, 25 SECONDS.
+This is not theoretical. An agent reads a web page, an email, a search
+result — anything an attacker can write to. The attacker hides an instruction.
+The agent obeys. OWASP ranks prompt injection as the number one risk for
+LLM applications. Now imagine that same agent is holding a private key.
+That's the world we're shipping into, and the existing wallet stack has
+no answer.</a:t>
             </a:r>
             <a:endParaRPr lang="en-US" dirty="0"/>
           </a:p>
@@ -1365,16 +1365,13 @@
           <a:p>
             <a:r>
               <a:rPr lang="en-US" dirty="0"/>
-              <a:t>SLIDE 4, 30 SECONDS.
-Here's where those five layers physically live. The SDK at the top —
-that's the single API. Inside the backend, the policy engine is the
-off-chain guard, AI guard catches the agent-specific threats. Below the
-bundler, the smart account has two validators: the owner key, used only
-for HUMAN-tier approvals through Privy — and the V2 session key, which
-covers both AUTO and GUARD tiers with on-chain caps the EVM enforces.
-Privy for identity, EIP-7702 to upgrade the EOA in place, ZeroDev Kernel
-for the validator modules. The next five slides zoom in on each
-numbered box.</a:t>
+              <a:t>SLIDE 4, 25 SECONDS.
+Three promises. One — your loss is bounded, hard ceiling, enforced by the
+EVM not by us. Two — your AI gets a sanity check, every signed intent is
+scanned for prompt injection before it ever reaches the chain. Three —
+you're the final word, the owner key lives in a trusted enclave that not
+even we can reach. The next three slides walk each one through a worst
+case.</a:t>
             </a:r>
             <a:endParaRPr lang="en-US" dirty="0"/>
           </a:p>
@@ -1462,14 +1459,13 @@
           <a:p>
             <a:r>
               <a:rPr lang="en-US" dirty="0"/>
-              <a:t>SLIDE 5, 30 SECONDS.
-The developer writes this. One construct, one fetch. No key handling,
-no tier branching, no bundler config. The agent calls a paywalled endpoint,
-server returns 402, SDK signs with the session key, retries with X-PAYMENT,
-gets the data. Three calls in a row settle on Base Sepolia in about four
-seconds each. And the on-chain cap means even if the agent goes rogue
-it can spend at most ten dollars a day. Everything on the next four slides
-is opt-in configuration on this same object.</a:t>
+              <a:t>SLIDE 5, 25 SECONDS.
+First promise: bounded loss. The daily cap is not a policy we promise to
+enforce — it's a validator module on the smart account. If our entire
+backend is breached tomorrow, the worst case is still ten dollars a day.
+On top of that we run TypeScript-side policies — recipient whitelists,
+slippage guards, rate limits — that the developer can hot-reload without
+redeploying anything. Belt and suspenders, but the belt is the EVM.</a:t>
             </a:r>
             <a:endParaRPr lang="en-US" dirty="0"/>
           </a:p>
@@ -1557,12 +1553,14 @@
           <a:p>
             <a:r>
               <a:rPr lang="en-US" dirty="0"/>
-              <a:t>SLIDE 6, 20 SECONDS.
-This is the hard guarantee. The cap lives on-chain as a validator module
-on the smart account. Not a backend check, not a policy, an EVM rule.
-If our entire infrastructure is compromised, the worst case is still
-bounded by the cap. Ten dollars a day is the demo default. Production
-users tune it down.</a:t>
+              <a:t>SLIDE 6, 25 SECONDS.
+Second promise: the AI gets a sanity check. Before any signature leaves
+the SDK, AI Guard compares what the user actually asked for against what
+the agent is about to sign. If those diverge — and they always do under
+prompt injection — the verdict is hostile, the path escalates to human
+approval, zero wei moves. And the scanner is an interface, not a single
+engine. We ship two providers, Lakera and Protect AI and Rebuff plug in
+post-hackathon with one config line.</a:t>
             </a:r>
             <a:endParaRPr lang="en-US" dirty="0"/>
           </a:p>
@@ -1650,11 +1648,13 @@
           <a:p>
             <a:r>
               <a:rPr lang="en-US" dirty="0"/>
-              <a:t>SLIDE 7, 20 SECONDS.
-On-chain limits are bounded but coarse. The off-chain layer adds the
-nuance — a recipient whitelist, a rate limit so the agent can't burn its
-daily cap in two seconds, a slippage guard for x402 paywalls.
-Plain TypeScript, hot-reloadable, no contract redeploy.</a:t>
+              <a:t>SLIDE 7, 25 SECONDS.
+Third promise: you are always the final word. The owner key is generated
+inside a trusted execution environment, signs inside it, and never exits
+it. Our servers can't see the key. If a transaction needs your approval —
+because it's over cap, off the whitelist, or AI-flagged — you get a push,
+you tap, the enclave signs. If you don't tap, the transaction rejects.
+Never silently waved through.</a:t>
             </a:r>
             <a:endParaRPr lang="en-US" dirty="0"/>
           </a:p>
@@ -1742,16 +1742,13 @@
           <a:p>
             <a:r>
               <a:rPr lang="en-US" dirty="0"/>
-              <a:t>SLIDE 8, 30 SECONDS.
-This is the layer that doesn't exist for normal wallets. A user types a
-question, an attacker has slipped a payload into the data the agent reads.
-The agent dutifully signs a drain. Our intent-diff provider compares what
-the user actually asked against what the agent is signing. Mismatch,
-verdict hostile, escalates to human, zero wei moved. And the provider
-interface is pluggable. We ship two providers today. Post-hackathon,
-Lakera, Protect AI, Rebuff plug in, developer toggles them on, we take a
-margin. Network effects: every new provider makes every existing developer
-safer. Marketplace, not a point tool.</a:t>
+              <a:t>SLIDE 8, 25 SECONDS.
+Everything we just promised lands behind one line for the developer.
+Construct an AgentGuard with their API key, await a fetch. The agent calls
+a paywalled endpoint, server returns 402, SDK signs with the bounded
+session key, retries, gets the data — about four seconds end to end on
+Base Sepolia. The developer never touches a key, never picks a tier.
+Defaults are safe.</a:t>
             </a:r>
             <a:endParaRPr lang="en-US" dirty="0"/>
           </a:p>
@@ -1839,12 +1836,15 @@
           <a:p>
             <a:r>
               <a:rPr lang="en-US" dirty="0"/>
-              <a:t>SLIDE 9, 20 SECONDS.
-The owner only sees a push when something genuinely needs them — over the
-cap, off the whitelist, or AI-flagged. They tap approve inside Privy,
-the owner key signs inside the TEE, the userop goes out. The backend
-never sees the key. And the default is fail-closed — if the owner is
-asleep, the transaction is rejected, not waved through.</a:t>
+              <a:t>SLIDE 9, 30 SECONDS.
+This is what's running today, not what's planned. Onboarding takes 30 seconds
+and ends with an API key the developer pastes into their agent. Policy editor
+hot-reloads. AI Guard catches intent drift live in the demo. Three execution
+tiers all wire into a single SDK call — the developer just awaits, the
+status field tells them which path was taken. x402 settles in about four
+seconds, which is the unit-economics number for micropayments. Emergency
+Stop is one Privy popup that sweeps the account and revokes the key in
+five seconds. Live URL is at the bottom — judges can sign up themselves.</a:t>
             </a:r>
             <a:endParaRPr lang="en-US" dirty="0"/>
           </a:p>

</xml_diff>